<commit_message>
fix: adjust image size so they're the same
</commit_message>
<xml_diff>
--- a/bachelor_thesis/docs/TB_affiche_ICNML.pptx
+++ b/bachelor_thesis/docs/TB_affiche_ICNML.pptx
@@ -4147,8 +4147,8 @@
         </p:blipFill>
         <p:spPr>
           <a:xfrm>
-            <a:off x="0" y="6579943"/>
-            <a:ext cx="6662356" cy="5336102"/>
+            <a:off x="0" y="7559675"/>
+            <a:ext cx="5439117" cy="4356369"/>
           </a:xfrm>
           <a:prstGeom prst="rect">
             <a:avLst/>
@@ -4171,8 +4171,8 @@
         </p:blipFill>
         <p:spPr>
           <a:xfrm>
-            <a:off x="6662356" y="8598793"/>
-            <a:ext cx="3996522" cy="3410506"/>
+            <a:off x="5586905" y="7559676"/>
+            <a:ext cx="5104908" cy="4356368"/>
           </a:xfrm>
           <a:prstGeom prst="rect">
             <a:avLst/>

</xml_diff>

<commit_message>
fix: add more info about the fact that the identifier can be used to accuse leaker
</commit_message>
<xml_diff>
--- a/bachelor_thesis/docs/TB_affiche_ICNML.pptx
+++ b/bachelor_thesis/docs/TB_affiche_ICNML.pptx
@@ -3574,7 +3574,7 @@
         <p:spPr>
           <a:xfrm>
             <a:off x="5345906" y="2885952"/>
-            <a:ext cx="4935202" cy="3323987"/>
+            <a:ext cx="4935202" cy="3754874"/>
           </a:xfrm>
           <a:prstGeom prst="rect">
             <a:avLst/>
@@ -3633,7 +3633,7 @@
                 <a:latin typeface="Arial" panose="020B0604020202020204" pitchFamily="34" charset="0"/>
                 <a:cs typeface="Arial" panose="020B0604020202020204" pitchFamily="34" charset="0"/>
               </a:rPr>
-              <a:t>absente du fond (figure de gauche).</a:t>
+              <a:t>absente du fond (figure de gauche). Identifiant permettant d’accuser la personne qui partage l’image en dehors du cadre de recherche.</a:t>
             </a:r>
             <a:br>
               <a:rPr lang="fr-CH" sz="1400" dirty="0">

</xml_diff>

<commit_message>
fix: better alignment of texts
</commit_message>
<xml_diff>
--- a/bachelor_thesis/docs/TB_affiche_ICNML.pptx
+++ b/bachelor_thesis/docs/TB_affiche_ICNML.pptx
@@ -4187,7 +4187,7 @@
         </p:nvSpPr>
         <p:spPr>
           <a:xfrm>
-            <a:off x="1061658" y="12009299"/>
+            <a:off x="918848" y="12009299"/>
             <a:ext cx="3894655" cy="830997"/>
           </a:xfrm>
           <a:prstGeom prst="rect">
@@ -4217,7 +4217,7 @@
         </p:nvSpPr>
         <p:spPr>
           <a:xfrm>
-            <a:off x="6844185" y="12132409"/>
+            <a:off x="6322927" y="12009299"/>
             <a:ext cx="3632864" cy="584775"/>
           </a:xfrm>
           <a:prstGeom prst="rect">

</xml_diff>

<commit_message>
fix: update poster with right orientation
</commit_message>
<xml_diff>
--- a/bachelor_thesis/docs/TB_affiche_ICNML.pptx
+++ b/bachelor_thesis/docs/TB_affiche_ICNML.pptx
@@ -3799,29 +3799,8 @@
                 <a:latin typeface="Arial" panose="020B0604020202020204" pitchFamily="34" charset="0"/>
                 <a:cs typeface="Arial" panose="020B0604020202020204" pitchFamily="34" charset="0"/>
               </a:rPr>
-              <a:t>Travail de </a:t>
-            </a:r>
-            <a:r>
-              <a:rPr lang="fr-CH" sz="2400" b="1" dirty="0" err="1">
-                <a:effectLst/>
-                <a:latin typeface="Arial" panose="020B0604020202020204" pitchFamily="34" charset="0"/>
-                <a:cs typeface="Arial" panose="020B0604020202020204" pitchFamily="34" charset="0"/>
-              </a:rPr>
-              <a:t>Bachelor</a:t>
-            </a:r>
-            <a:r>
-              <a:rPr lang="fr-CH" sz="2400" b="1">
-                <a:effectLst/>
-                <a:latin typeface="Arial" panose="020B0604020202020204" pitchFamily="34" charset="0"/>
-                <a:cs typeface="Arial" panose="020B0604020202020204" pitchFamily="34" charset="0"/>
-              </a:rPr>
-              <a:t> 2026</a:t>
-            </a:r>
-            <a:endParaRPr lang="fr-CH" sz="2400" b="1" dirty="0">
-              <a:effectLst/>
-              <a:latin typeface="Arial" panose="020B0604020202020204" pitchFamily="34" charset="0"/>
-              <a:cs typeface="Arial" panose="020B0604020202020204" pitchFamily="34" charset="0"/>
-            </a:endParaRPr>
+              <a:t>Travail de Bachelor 2026</a:t>
+            </a:r>
           </a:p>
           <a:p>
             <a:pPr algn="r"/>
@@ -3846,7 +3825,7 @@
                 <a:latin typeface="Arial" panose="020B0604020202020204" pitchFamily="34" charset="0"/>
                 <a:cs typeface="Arial" panose="020B0604020202020204" pitchFamily="34" charset="0"/>
               </a:rPr>
-              <a:t>Orientation ISCE </a:t>
+              <a:t>Orientation ISCL </a:t>
             </a:r>
             <a:endParaRPr lang="fr-CH" sz="2400" dirty="0">
               <a:effectLst/>
@@ -4883,12 +4862,12 @@
 </file>
 
 <file path=customXml/item1.xml><?xml version="1.0" encoding="utf-8"?>
-<?mso-contentType ?>
-<FormTemplates xmlns="http://schemas.microsoft.com/sharepoint/v3/contenttype/forms">
-  <Display>DocumentLibraryForm</Display>
-  <Edit>DocumentLibraryForm</Edit>
-  <New>DocumentLibraryForm</New>
-</FormTemplates>
+<p:properties xmlns:p="http://schemas.microsoft.com/office/2006/metadata/properties" xmlns:xsi="http://www.w3.org/2001/XMLSchema-instance" xmlns:pc="http://schemas.microsoft.com/office/infopath/2007/PartnerControls">
+  <documentManagement>
+    <PublishingExpirationDate xmlns="http://schemas.microsoft.com/sharepoint/v3" xsi:nil="true"/>
+    <PublishingStartDate xmlns="http://schemas.microsoft.com/sharepoint/v3" xsi:nil="true"/>
+  </documentManagement>
+</p:properties>
 </file>
 
 <file path=customXml/item2.xml><?xml version="1.0" encoding="utf-8"?>
@@ -5024,18 +5003,20 @@
 </file>
 
 <file path=customXml/item3.xml><?xml version="1.0" encoding="utf-8"?>
-<p:properties xmlns:p="http://schemas.microsoft.com/office/2006/metadata/properties" xmlns:xsi="http://www.w3.org/2001/XMLSchema-instance" xmlns:pc="http://schemas.microsoft.com/office/infopath/2007/PartnerControls">
-  <documentManagement>
-    <PublishingExpirationDate xmlns="http://schemas.microsoft.com/sharepoint/v3" xsi:nil="true"/>
-    <PublishingStartDate xmlns="http://schemas.microsoft.com/sharepoint/v3" xsi:nil="true"/>
-  </documentManagement>
-</p:properties>
+<?mso-contentType ?>
+<FormTemplates xmlns="http://schemas.microsoft.com/sharepoint/v3/contenttype/forms">
+  <Display>DocumentLibraryForm</Display>
+  <Edit>DocumentLibraryForm</Edit>
+  <New>DocumentLibraryForm</New>
+</FormTemplates>
 </file>
 
 <file path=customXml/itemProps1.xml><?xml version="1.0" encoding="utf-8"?>
-<ds:datastoreItem xmlns:ds="http://schemas.openxmlformats.org/officeDocument/2006/customXml" ds:itemID="{3FAAD471-60E3-4269-8F77-1FB8D65951AF}">
+<ds:datastoreItem xmlns:ds="http://schemas.openxmlformats.org/officeDocument/2006/customXml" ds:itemID="{78925618-3156-4746-8B68-5C33F2AB0FD4}">
   <ds:schemaRefs>
-    <ds:schemaRef ds:uri="http://schemas.microsoft.com/sharepoint/v3/contenttype/forms"/>
+    <ds:schemaRef ds:uri="http://schemas.microsoft.com/office/2006/metadata/properties"/>
+    <ds:schemaRef ds:uri="http://schemas.microsoft.com/office/infopath/2007/PartnerControls"/>
+    <ds:schemaRef ds:uri="http://schemas.microsoft.com/sharepoint/v3"/>
   </ds:schemaRefs>
 </ds:datastoreItem>
 </file>
@@ -5059,11 +5040,9 @@
 </file>
 
 <file path=customXml/itemProps3.xml><?xml version="1.0" encoding="utf-8"?>
-<ds:datastoreItem xmlns:ds="http://schemas.openxmlformats.org/officeDocument/2006/customXml" ds:itemID="{78925618-3156-4746-8B68-5C33F2AB0FD4}">
+<ds:datastoreItem xmlns:ds="http://schemas.openxmlformats.org/officeDocument/2006/customXml" ds:itemID="{3FAAD471-60E3-4269-8F77-1FB8D65951AF}">
   <ds:schemaRefs>
-    <ds:schemaRef ds:uri="http://schemas.microsoft.com/office/2006/metadata/properties"/>
-    <ds:schemaRef ds:uri="http://schemas.microsoft.com/office/infopath/2007/PartnerControls"/>
-    <ds:schemaRef ds:uri="http://schemas.microsoft.com/sharepoint/v3"/>
+    <ds:schemaRef ds:uri="http://schemas.microsoft.com/sharepoint/v3/contenttype/forms"/>
   </ds:schemaRefs>
 </ds:datastoreItem>
 </file>
</xml_diff>